<commit_message>
Updated charter and slides
</commit_message>
<xml_diff>
--- a/HostIt_Project_Charter_Pitch.pptx
+++ b/HostIt_Project_Charter_Pitch.pptx
@@ -308,7 +308,7 @@
           <a:p>
             <a:fld id="{5BCAD085-E8A6-8845-BD4E-CB4CCA059FC4}" type="datetimeFigureOut">
               <a:rPr lang="en-US" smtClean="0"/>
-              <a:t>10/5/2026</a:t>
+              <a:t>10/7/2026</a:t>
             </a:fld>
             <a:endParaRPr lang="en-US"/>
           </a:p>
@@ -476,7 +476,7 @@
           <a:p>
             <a:fld id="{5BCAD085-E8A6-8845-BD4E-CB4CCA059FC4}" type="datetimeFigureOut">
               <a:rPr lang="en-US" smtClean="0"/>
-              <a:t>10/5/2026</a:t>
+              <a:t>10/7/2026</a:t>
             </a:fld>
             <a:endParaRPr lang="en-US"/>
           </a:p>
@@ -654,7 +654,7 @@
           <a:p>
             <a:fld id="{5BCAD085-E8A6-8845-BD4E-CB4CCA059FC4}" type="datetimeFigureOut">
               <a:rPr lang="en-US" smtClean="0"/>
-              <a:t>10/5/2026</a:t>
+              <a:t>10/7/2026</a:t>
             </a:fld>
             <a:endParaRPr lang="en-US"/>
           </a:p>
@@ -822,7 +822,7 @@
           <a:p>
             <a:fld id="{5BCAD085-E8A6-8845-BD4E-CB4CCA059FC4}" type="datetimeFigureOut">
               <a:rPr lang="en-US" smtClean="0"/>
-              <a:t>10/5/2026</a:t>
+              <a:t>10/7/2026</a:t>
             </a:fld>
             <a:endParaRPr lang="en-US"/>
           </a:p>
@@ -1067,7 +1067,7 @@
           <a:p>
             <a:fld id="{5BCAD085-E8A6-8845-BD4E-CB4CCA059FC4}" type="datetimeFigureOut">
               <a:rPr lang="en-US" smtClean="0"/>
-              <a:t>10/5/2026</a:t>
+              <a:t>10/7/2026</a:t>
             </a:fld>
             <a:endParaRPr lang="en-US"/>
           </a:p>
@@ -1352,7 +1352,7 @@
           <a:p>
             <a:fld id="{5BCAD085-E8A6-8845-BD4E-CB4CCA059FC4}" type="datetimeFigureOut">
               <a:rPr lang="en-US" smtClean="0"/>
-              <a:t>10/5/2026</a:t>
+              <a:t>10/7/2026</a:t>
             </a:fld>
             <a:endParaRPr lang="en-US"/>
           </a:p>
@@ -1771,7 +1771,7 @@
           <a:p>
             <a:fld id="{5BCAD085-E8A6-8845-BD4E-CB4CCA059FC4}" type="datetimeFigureOut">
               <a:rPr lang="en-US" smtClean="0"/>
-              <a:t>10/5/2026</a:t>
+              <a:t>10/7/2026</a:t>
             </a:fld>
             <a:endParaRPr lang="en-US"/>
           </a:p>
@@ -1888,7 +1888,7 @@
           <a:p>
             <a:fld id="{5BCAD085-E8A6-8845-BD4E-CB4CCA059FC4}" type="datetimeFigureOut">
               <a:rPr lang="en-US" smtClean="0"/>
-              <a:t>10/5/2026</a:t>
+              <a:t>10/7/2026</a:t>
             </a:fld>
             <a:endParaRPr lang="en-US"/>
           </a:p>
@@ -1983,7 +1983,7 @@
           <a:p>
             <a:fld id="{5BCAD085-E8A6-8845-BD4E-CB4CCA059FC4}" type="datetimeFigureOut">
               <a:rPr lang="en-US" smtClean="0"/>
-              <a:t>10/5/2026</a:t>
+              <a:t>10/7/2026</a:t>
             </a:fld>
             <a:endParaRPr lang="en-US"/>
           </a:p>
@@ -2258,7 +2258,7 @@
           <a:p>
             <a:fld id="{5BCAD085-E8A6-8845-BD4E-CB4CCA059FC4}" type="datetimeFigureOut">
               <a:rPr lang="en-US" smtClean="0"/>
-              <a:t>10/5/2026</a:t>
+              <a:t>10/7/2026</a:t>
             </a:fld>
             <a:endParaRPr lang="en-US"/>
           </a:p>
@@ -2510,7 +2510,7 @@
           <a:p>
             <a:fld id="{5BCAD085-E8A6-8845-BD4E-CB4CCA059FC4}" type="datetimeFigureOut">
               <a:rPr lang="en-US" smtClean="0"/>
-              <a:t>10/5/2026</a:t>
+              <a:t>10/7/2026</a:t>
             </a:fld>
             <a:endParaRPr lang="en-US"/>
           </a:p>
@@ -2721,7 +2721,7 @@
           <a:p>
             <a:fld id="{5BCAD085-E8A6-8845-BD4E-CB4CCA059FC4}" type="datetimeFigureOut">
               <a:rPr lang="en-US" smtClean="0"/>
-              <a:t>10/5/2026</a:t>
+              <a:t>10/7/2026</a:t>
             </a:fld>
             <a:endParaRPr lang="en-US"/>
           </a:p>
@@ -3376,7 +3376,7 @@
         <p:spPr>
           <a:xfrm>
             <a:off x="8046720" y="2075688"/>
-            <a:ext cx="3017520" cy="2514600"/>
+            <a:ext cx="3017520" cy="892552"/>
           </a:xfrm>
           <a:prstGeom prst="rect">
             <a:avLst/>
@@ -3400,7 +3400,12 @@
               </a:defRPr>
             </a:pPr>
             <a:r>
-              <a:t>• Sponsor: MCDA 5510 instructors</a:t>
+              <a:rPr dirty="0"/>
+              <a:t>• Sponsor: </a:t>
+            </a:r>
+            <a:r>
+              <a:rPr lang="en-CA" dirty="0"/>
+              <a:t>Sam &amp; Armaan</a:t>
             </a:r>
           </a:p>
           <a:p>
@@ -3415,6 +3420,7 @@
               </a:defRPr>
             </a:pPr>
             <a:r>
+              <a:rPr dirty="0"/>
               <a:t>• Project managers: Sam &amp; Armaan</a:t>
             </a:r>
           </a:p>
@@ -3430,6 +3436,7 @@
               </a:defRPr>
             </a:pPr>
             <a:r>
+              <a:rPr dirty="0"/>
               <a:t>• Charter date: October 7</a:t>
             </a:r>
           </a:p>

</xml_diff>